<commit_message>
Move shared functions to new utils file
</commit_message>
<xml_diff>
--- a/Presentation1.pptx
+++ b/Presentation1.pptx
@@ -107,7 +107,7 @@
   <p:extLst>
     <p:ext uri="{EFAFB233-063F-42B5-8137-9DF3F51BA10A}">
       <p15:sldGuideLst xmlns:p15="http://schemas.microsoft.com/office/powerpoint/2012/main">
-        <p15:guide id="1" orient="horz" pos="9535" userDrawn="1">
+        <p15:guide id="1" orient="horz" pos="9558" userDrawn="1">
           <p15:clr>
             <a:srgbClr val="A4A3A4"/>
           </p15:clr>
@@ -272,7 +272,7 @@
           <a:p>
             <a:fld id="{9BA507A8-AB1E-4362-AD52-AB8FDE0591EF}" type="datetimeFigureOut">
               <a:rPr lang="en-GB" smtClean="0"/>
-              <a:t>24/03/2026</a:t>
+              <a:t>29/03/2026</a:t>
             </a:fld>
             <a:endParaRPr lang="en-GB"/>
           </a:p>
@@ -472,7 +472,7 @@
           <a:p>
             <a:fld id="{9BA507A8-AB1E-4362-AD52-AB8FDE0591EF}" type="datetimeFigureOut">
               <a:rPr lang="en-GB" smtClean="0"/>
-              <a:t>24/03/2026</a:t>
+              <a:t>29/03/2026</a:t>
             </a:fld>
             <a:endParaRPr lang="en-GB"/>
           </a:p>
@@ -682,7 +682,7 @@
           <a:p>
             <a:fld id="{9BA507A8-AB1E-4362-AD52-AB8FDE0591EF}" type="datetimeFigureOut">
               <a:rPr lang="en-GB" smtClean="0"/>
-              <a:t>24/03/2026</a:t>
+              <a:t>29/03/2026</a:t>
             </a:fld>
             <a:endParaRPr lang="en-GB"/>
           </a:p>
@@ -882,7 +882,7 @@
           <a:p>
             <a:fld id="{9BA507A8-AB1E-4362-AD52-AB8FDE0591EF}" type="datetimeFigureOut">
               <a:rPr lang="en-GB" smtClean="0"/>
-              <a:t>24/03/2026</a:t>
+              <a:t>29/03/2026</a:t>
             </a:fld>
             <a:endParaRPr lang="en-GB"/>
           </a:p>
@@ -1158,7 +1158,7 @@
           <a:p>
             <a:fld id="{9BA507A8-AB1E-4362-AD52-AB8FDE0591EF}" type="datetimeFigureOut">
               <a:rPr lang="en-GB" smtClean="0"/>
-              <a:t>24/03/2026</a:t>
+              <a:t>29/03/2026</a:t>
             </a:fld>
             <a:endParaRPr lang="en-GB"/>
           </a:p>
@@ -1426,7 +1426,7 @@
           <a:p>
             <a:fld id="{9BA507A8-AB1E-4362-AD52-AB8FDE0591EF}" type="datetimeFigureOut">
               <a:rPr lang="en-GB" smtClean="0"/>
-              <a:t>24/03/2026</a:t>
+              <a:t>29/03/2026</a:t>
             </a:fld>
             <a:endParaRPr lang="en-GB"/>
           </a:p>
@@ -1841,7 +1841,7 @@
           <a:p>
             <a:fld id="{9BA507A8-AB1E-4362-AD52-AB8FDE0591EF}" type="datetimeFigureOut">
               <a:rPr lang="en-GB" smtClean="0"/>
-              <a:t>24/03/2026</a:t>
+              <a:t>29/03/2026</a:t>
             </a:fld>
             <a:endParaRPr lang="en-GB"/>
           </a:p>
@@ -1983,7 +1983,7 @@
           <a:p>
             <a:fld id="{9BA507A8-AB1E-4362-AD52-AB8FDE0591EF}" type="datetimeFigureOut">
               <a:rPr lang="en-GB" smtClean="0"/>
-              <a:t>24/03/2026</a:t>
+              <a:t>29/03/2026</a:t>
             </a:fld>
             <a:endParaRPr lang="en-GB"/>
           </a:p>
@@ -2096,7 +2096,7 @@
           <a:p>
             <a:fld id="{9BA507A8-AB1E-4362-AD52-AB8FDE0591EF}" type="datetimeFigureOut">
               <a:rPr lang="en-GB" smtClean="0"/>
-              <a:t>24/03/2026</a:t>
+              <a:t>29/03/2026</a:t>
             </a:fld>
             <a:endParaRPr lang="en-GB"/>
           </a:p>
@@ -2409,7 +2409,7 @@
           <a:p>
             <a:fld id="{9BA507A8-AB1E-4362-AD52-AB8FDE0591EF}" type="datetimeFigureOut">
               <a:rPr lang="en-GB" smtClean="0"/>
-              <a:t>24/03/2026</a:t>
+              <a:t>29/03/2026</a:t>
             </a:fld>
             <a:endParaRPr lang="en-GB"/>
           </a:p>
@@ -2698,7 +2698,7 @@
           <a:p>
             <a:fld id="{9BA507A8-AB1E-4362-AD52-AB8FDE0591EF}" type="datetimeFigureOut">
               <a:rPr lang="en-GB" smtClean="0"/>
-              <a:t>24/03/2026</a:t>
+              <a:t>29/03/2026</a:t>
             </a:fld>
             <a:endParaRPr lang="en-GB"/>
           </a:p>
@@ -2941,7 +2941,7 @@
           <a:p>
             <a:fld id="{9BA507A8-AB1E-4362-AD52-AB8FDE0591EF}" type="datetimeFigureOut">
               <a:rPr lang="en-GB" smtClean="0"/>
-              <a:t>24/03/2026</a:t>
+              <a:t>29/03/2026</a:t>
             </a:fld>
             <a:endParaRPr lang="en-GB"/>
           </a:p>
@@ -3344,6 +3344,14 @@
 <file path=ppt/slides/slide1.xml><?xml version="1.0" encoding="utf-8"?>
 <p:sld xmlns:a="http://schemas.openxmlformats.org/drawingml/2006/main" xmlns:r="http://schemas.openxmlformats.org/officeDocument/2006/relationships" xmlns:p="http://schemas.openxmlformats.org/presentationml/2006/main">
   <p:cSld>
+    <p:bg>
+      <p:bgPr>
+        <a:solidFill>
+          <a:schemeClr val="accent1"/>
+        </a:solidFill>
+        <a:effectLst/>
+      </p:bgPr>
+    </p:bg>
     <p:spTree>
       <p:nvGrpSpPr>
         <p:cNvPr id="1" name=""/>
@@ -3360,6 +3368,226 @@
       </p:grpSpPr>
       <p:sp>
         <p:nvSpPr>
+          <p:cNvPr id="48" name="Rectangle: Rounded Corners 47">
+            <a:extLst>
+              <a:ext uri="{FF2B5EF4-FFF2-40B4-BE49-F238E27FC236}">
+                <a16:creationId xmlns:a16="http://schemas.microsoft.com/office/drawing/2014/main" id="{2A57AD61-35B5-3784-1311-F9D7D4A9B72D}"/>
+              </a:ext>
+            </a:extLst>
+          </p:cNvPr>
+          <p:cNvSpPr/>
+          <p:nvPr/>
+        </p:nvSpPr>
+        <p:spPr>
+          <a:xfrm>
+            <a:off x="461249" y="11466018"/>
+            <a:ext cx="9957091" cy="5824704"/>
+          </a:xfrm>
+          <a:prstGeom prst="roundRect">
+            <a:avLst/>
+          </a:prstGeom>
+          <a:solidFill>
+            <a:schemeClr val="bg1"/>
+          </a:solidFill>
+          <a:ln w="254000">
+            <a:solidFill>
+              <a:schemeClr val="tx2"/>
+            </a:solidFill>
+          </a:ln>
+        </p:spPr>
+        <p:style>
+          <a:lnRef idx="1">
+            <a:schemeClr val="accent4"/>
+          </a:lnRef>
+          <a:fillRef idx="2">
+            <a:schemeClr val="accent4"/>
+          </a:fillRef>
+          <a:effectRef idx="1">
+            <a:schemeClr val="accent4"/>
+          </a:effectRef>
+          <a:fontRef idx="minor">
+            <a:schemeClr val="dk1"/>
+          </a:fontRef>
+        </p:style>
+        <p:txBody>
+          <a:bodyPr rtlCol="0" anchor="ctr"/>
+          <a:lstStyle/>
+          <a:p>
+            <a:endParaRPr lang="en-GB" sz="1600" b="1" dirty="0">
+              <a:latin typeface="Calibri" panose="020F0502020204030204" pitchFamily="34" charset="0"/>
+              <a:ea typeface="Calibri" panose="020F0502020204030204" pitchFamily="34" charset="0"/>
+              <a:cs typeface="Calibri" panose="020F0502020204030204" pitchFamily="34" charset="0"/>
+            </a:endParaRPr>
+          </a:p>
+        </p:txBody>
+      </p:sp>
+      <p:sp>
+        <p:nvSpPr>
+          <p:cNvPr id="42" name="Rectangle: Rounded Corners 41">
+            <a:extLst>
+              <a:ext uri="{FF2B5EF4-FFF2-40B4-BE49-F238E27FC236}">
+                <a16:creationId xmlns:a16="http://schemas.microsoft.com/office/drawing/2014/main" id="{1B2A54CB-0C2C-3886-72E2-464C7E336086}"/>
+              </a:ext>
+            </a:extLst>
+          </p:cNvPr>
+          <p:cNvSpPr/>
+          <p:nvPr/>
+        </p:nvSpPr>
+        <p:spPr>
+          <a:xfrm>
+            <a:off x="445553" y="23936248"/>
+            <a:ext cx="9957091" cy="5824704"/>
+          </a:xfrm>
+          <a:prstGeom prst="roundRect">
+            <a:avLst/>
+          </a:prstGeom>
+          <a:solidFill>
+            <a:schemeClr val="bg1"/>
+          </a:solidFill>
+          <a:ln w="254000">
+            <a:solidFill>
+              <a:schemeClr val="tx2"/>
+            </a:solidFill>
+          </a:ln>
+        </p:spPr>
+        <p:style>
+          <a:lnRef idx="1">
+            <a:schemeClr val="accent4"/>
+          </a:lnRef>
+          <a:fillRef idx="2">
+            <a:schemeClr val="accent4"/>
+          </a:fillRef>
+          <a:effectRef idx="1">
+            <a:schemeClr val="accent4"/>
+          </a:effectRef>
+          <a:fontRef idx="minor">
+            <a:schemeClr val="dk1"/>
+          </a:fontRef>
+        </p:style>
+        <p:txBody>
+          <a:bodyPr rtlCol="0" anchor="ctr"/>
+          <a:lstStyle/>
+          <a:p>
+            <a:endParaRPr lang="en-GB" sz="1600" b="1" dirty="0">
+              <a:latin typeface="Calibri" panose="020F0502020204030204" pitchFamily="34" charset="0"/>
+              <a:ea typeface="Calibri" panose="020F0502020204030204" pitchFamily="34" charset="0"/>
+              <a:cs typeface="Calibri" panose="020F0502020204030204" pitchFamily="34" charset="0"/>
+            </a:endParaRPr>
+          </a:p>
+        </p:txBody>
+      </p:sp>
+      <p:sp>
+        <p:nvSpPr>
+          <p:cNvPr id="46" name="Rectangle: Rounded Corners 45">
+            <a:extLst>
+              <a:ext uri="{FF2B5EF4-FFF2-40B4-BE49-F238E27FC236}">
+                <a16:creationId xmlns:a16="http://schemas.microsoft.com/office/drawing/2014/main" id="{FCB0D5D0-BACD-3844-6C3C-63D2267AA785}"/>
+              </a:ext>
+            </a:extLst>
+          </p:cNvPr>
+          <p:cNvSpPr/>
+          <p:nvPr/>
+        </p:nvSpPr>
+        <p:spPr>
+          <a:xfrm>
+            <a:off x="10978646" y="17778247"/>
+            <a:ext cx="9957091" cy="5824704"/>
+          </a:xfrm>
+          <a:prstGeom prst="roundRect">
+            <a:avLst/>
+          </a:prstGeom>
+          <a:solidFill>
+            <a:schemeClr val="bg1"/>
+          </a:solidFill>
+          <a:ln w="254000">
+            <a:solidFill>
+              <a:schemeClr val="tx2"/>
+            </a:solidFill>
+          </a:ln>
+        </p:spPr>
+        <p:style>
+          <a:lnRef idx="1">
+            <a:schemeClr val="accent4"/>
+          </a:lnRef>
+          <a:fillRef idx="2">
+            <a:schemeClr val="accent4"/>
+          </a:fillRef>
+          <a:effectRef idx="1">
+            <a:schemeClr val="accent4"/>
+          </a:effectRef>
+          <a:fontRef idx="minor">
+            <a:schemeClr val="dk1"/>
+          </a:fontRef>
+        </p:style>
+        <p:txBody>
+          <a:bodyPr rtlCol="0" anchor="ctr"/>
+          <a:lstStyle/>
+          <a:p>
+            <a:endParaRPr lang="en-GB" sz="1600" b="1" dirty="0">
+              <a:latin typeface="Calibri" panose="020F0502020204030204" pitchFamily="34" charset="0"/>
+              <a:ea typeface="Calibri" panose="020F0502020204030204" pitchFamily="34" charset="0"/>
+              <a:cs typeface="Calibri" panose="020F0502020204030204" pitchFamily="34" charset="0"/>
+            </a:endParaRPr>
+          </a:p>
+        </p:txBody>
+      </p:sp>
+      <p:sp>
+        <p:nvSpPr>
+          <p:cNvPr id="36" name="Rectangle: Rounded Corners 35">
+            <a:extLst>
+              <a:ext uri="{FF2B5EF4-FFF2-40B4-BE49-F238E27FC236}">
+                <a16:creationId xmlns:a16="http://schemas.microsoft.com/office/drawing/2014/main" id="{06D4043B-6B0A-E807-297A-78F228CBBFA8}"/>
+              </a:ext>
+            </a:extLst>
+          </p:cNvPr>
+          <p:cNvSpPr/>
+          <p:nvPr/>
+        </p:nvSpPr>
+        <p:spPr>
+          <a:xfrm>
+            <a:off x="10978646" y="3588017"/>
+            <a:ext cx="9943729" cy="7423380"/>
+          </a:xfrm>
+          <a:prstGeom prst="roundRect">
+            <a:avLst/>
+          </a:prstGeom>
+          <a:solidFill>
+            <a:schemeClr val="bg1"/>
+          </a:solidFill>
+          <a:ln w="254000">
+            <a:solidFill>
+              <a:schemeClr val="tx2"/>
+            </a:solidFill>
+          </a:ln>
+        </p:spPr>
+        <p:style>
+          <a:lnRef idx="1">
+            <a:schemeClr val="accent4"/>
+          </a:lnRef>
+          <a:fillRef idx="2">
+            <a:schemeClr val="accent4"/>
+          </a:fillRef>
+          <a:effectRef idx="1">
+            <a:schemeClr val="accent4"/>
+          </a:effectRef>
+          <a:fontRef idx="minor">
+            <a:schemeClr val="dk1"/>
+          </a:fontRef>
+        </p:style>
+        <p:txBody>
+          <a:bodyPr rtlCol="0" anchor="ctr"/>
+          <a:lstStyle/>
+          <a:p>
+            <a:endParaRPr lang="en-GB" sz="1600" b="1" dirty="0">
+              <a:latin typeface="Calibri" panose="020F0502020204030204" pitchFamily="34" charset="0"/>
+              <a:ea typeface="Calibri" panose="020F0502020204030204" pitchFamily="34" charset="0"/>
+              <a:cs typeface="Calibri" panose="020F0502020204030204" pitchFamily="34" charset="0"/>
+            </a:endParaRPr>
+          </a:p>
+        </p:txBody>
+      </p:sp>
+      <p:sp>
+        <p:nvSpPr>
           <p:cNvPr id="4" name="Rectangle 3">
             <a:extLst>
               <a:ext uri="{FF2B5EF4-FFF2-40B4-BE49-F238E27FC236}">
@@ -3373,11 +3601,14 @@
         <p:spPr>
           <a:xfrm>
             <a:off x="1" y="0"/>
-            <a:ext cx="21383624" cy="3755571"/>
+            <a:ext cx="21383624" cy="3425125"/>
           </a:xfrm>
           <a:prstGeom prst="rect">
             <a:avLst/>
           </a:prstGeom>
+          <a:solidFill>
+            <a:schemeClr val="accent1"/>
+          </a:solidFill>
           <a:ln>
             <a:solidFill>
               <a:schemeClr val="accent1"/>
@@ -3406,7 +3637,7 @@
           <a:p>
             <a:pPr algn="ctr"/>
             <a:r>
-              <a:rPr lang="en-GB" sz="7200" b="1" dirty="0">
+              <a:rPr lang="en-GB" sz="5400" b="1" dirty="0">
                 <a:latin typeface="Calibri" panose="020F0502020204030204" pitchFamily="34" charset="0"/>
                 <a:ea typeface="Calibri" panose="020F0502020204030204" pitchFamily="34" charset="0"/>
                 <a:cs typeface="Calibri" panose="020F0502020204030204" pitchFamily="34" charset="0"/>
@@ -3414,14 +3645,14 @@
               <a:t>Using Machine Learning to Understand and </a:t>
             </a:r>
             <a:br>
-              <a:rPr lang="en-GB" sz="7200" b="1" dirty="0">
+              <a:rPr lang="en-GB" sz="5400" b="1" dirty="0">
                 <a:latin typeface="Calibri" panose="020F0502020204030204" pitchFamily="34" charset="0"/>
                 <a:ea typeface="Calibri" panose="020F0502020204030204" pitchFamily="34" charset="0"/>
                 <a:cs typeface="Calibri" panose="020F0502020204030204" pitchFamily="34" charset="0"/>
               </a:rPr>
             </a:br>
             <a:r>
-              <a:rPr lang="en-GB" sz="7200" b="1" dirty="0">
+              <a:rPr lang="en-GB" sz="5400" b="1" dirty="0">
                 <a:latin typeface="Calibri" panose="020F0502020204030204" pitchFamily="34" charset="0"/>
                 <a:ea typeface="Calibri" panose="020F0502020204030204" pitchFamily="34" charset="0"/>
                 <a:cs typeface="Calibri" panose="020F0502020204030204" pitchFamily="34" charset="0"/>
@@ -3485,8 +3716,8 @@
         </p:blipFill>
         <p:spPr>
           <a:xfrm>
-            <a:off x="195942" y="26702906"/>
-            <a:ext cx="3396344" cy="3396344"/>
+            <a:off x="1301706" y="25785139"/>
+            <a:ext cx="2126922" cy="2126922"/>
           </a:xfrm>
           <a:prstGeom prst="rect">
             <a:avLst/>
@@ -3507,12 +3738,20 @@
         </p:nvSpPr>
         <p:spPr>
           <a:xfrm>
-            <a:off x="228599" y="4249452"/>
-            <a:ext cx="10123714" cy="6834548"/>
+            <a:off x="490047" y="3588017"/>
+            <a:ext cx="9972463" cy="3300122"/>
           </a:xfrm>
           <a:prstGeom prst="roundRect">
             <a:avLst/>
           </a:prstGeom>
+          <a:solidFill>
+            <a:schemeClr val="bg1"/>
+          </a:solidFill>
+          <a:ln w="254000">
+            <a:solidFill>
+              <a:schemeClr val="tx2"/>
+            </a:solidFill>
+          </a:ln>
         </p:spPr>
         <p:style>
           <a:lnRef idx="1">
@@ -3533,7 +3772,7 @@
           <a:lstStyle/>
           <a:p>
             <a:r>
-              <a:rPr lang="en-GB" sz="4400" b="1" dirty="0">
+              <a:rPr lang="en-GB" sz="2400" b="1" dirty="0">
                 <a:solidFill>
                   <a:schemeClr val="tx1"/>
                 </a:solidFill>
@@ -3546,7 +3785,7 @@
           </a:p>
           <a:p>
             <a:r>
-              <a:rPr lang="en-GB" sz="2400" dirty="0">
+              <a:rPr lang="en-GB" sz="1600" dirty="0">
                 <a:solidFill>
                   <a:schemeClr val="tx1"/>
                 </a:solidFill>
@@ -3559,7 +3798,7 @@
           </a:p>
           <a:p>
             <a:r>
-              <a:rPr lang="en-GB" sz="2400" b="1" dirty="0">
+              <a:rPr lang="en-GB" sz="1600" b="1" dirty="0">
                 <a:solidFill>
                   <a:schemeClr val="tx1"/>
                 </a:solidFill>
@@ -3569,7 +3808,7 @@
               </a:rPr>
               <a:t>This project aimed to build a ML system capable of extracting driving behaviour features from real Formula One race telemetry as well as sim racing video game telemetry to provide real-time feedback to drivers on how to improve their lap times.</a:t>
             </a:r>
-            <a:endParaRPr lang="en-GB" sz="4400" dirty="0">
+            <a:endParaRPr lang="en-GB" sz="1600" dirty="0">
               <a:solidFill>
                 <a:schemeClr val="tx1"/>
               </a:solidFill>
@@ -3582,10 +3821,10 @@
       </p:sp>
       <p:sp>
         <p:nvSpPr>
-          <p:cNvPr id="12" name="Rectangle: Rounded Corners 11">
-            <a:extLst>
-              <a:ext uri="{FF2B5EF4-FFF2-40B4-BE49-F238E27FC236}">
-                <a16:creationId xmlns:a16="http://schemas.microsoft.com/office/drawing/2014/main" id="{1E7C8517-C347-4A68-733D-F48EEECE3B89}"/>
+          <p:cNvPr id="14" name="Rectangle: Rounded Corners 13">
+            <a:extLst>
+              <a:ext uri="{FF2B5EF4-FFF2-40B4-BE49-F238E27FC236}">
+                <a16:creationId xmlns:a16="http://schemas.microsoft.com/office/drawing/2014/main" id="{8E6298C8-913F-3313-A467-E69E9967C7E6}"/>
               </a:ext>
             </a:extLst>
           </p:cNvPr>
@@ -3594,12 +3833,20 @@
         </p:nvSpPr>
         <p:spPr>
           <a:xfrm>
-            <a:off x="11031312" y="9797144"/>
-            <a:ext cx="10123714" cy="6834549"/>
+            <a:off x="443218" y="17778247"/>
+            <a:ext cx="9957091" cy="5824704"/>
           </a:xfrm>
           <a:prstGeom prst="roundRect">
             <a:avLst/>
           </a:prstGeom>
+          <a:solidFill>
+            <a:schemeClr val="bg1"/>
+          </a:solidFill>
+          <a:ln w="254000">
+            <a:solidFill>
+              <a:schemeClr val="tx2"/>
+            </a:solidFill>
+          </a:ln>
         </p:spPr>
         <p:style>
           <a:lnRef idx="1">
@@ -3620,27 +3867,12 @@
           <a:lstStyle/>
           <a:p>
             <a:r>
-              <a:rPr lang="en-GB" sz="4400" b="1" dirty="0">
-                <a:latin typeface="Calibri" panose="020F0502020204030204" pitchFamily="34" charset="0"/>
-                <a:ea typeface="Calibri" panose="020F0502020204030204" pitchFamily="34" charset="0"/>
-                <a:cs typeface="Calibri" panose="020F0502020204030204" pitchFamily="34" charset="0"/>
-              </a:rPr>
-              <a:t>Datasets &amp; Models:</a:t>
-            </a:r>
-            <a:br>
-              <a:rPr lang="en-GB" sz="4400" b="1" dirty="0">
-                <a:latin typeface="Calibri" panose="020F0502020204030204" pitchFamily="34" charset="0"/>
-                <a:ea typeface="Calibri" panose="020F0502020204030204" pitchFamily="34" charset="0"/>
-                <a:cs typeface="Calibri" panose="020F0502020204030204" pitchFamily="34" charset="0"/>
-              </a:rPr>
-            </a:br>
-            <a:r>
               <a:rPr lang="en-GB" sz="2400" b="1" dirty="0">
                 <a:latin typeface="Calibri" panose="020F0502020204030204" pitchFamily="34" charset="0"/>
                 <a:ea typeface="Calibri" panose="020F0502020204030204" pitchFamily="34" charset="0"/>
                 <a:cs typeface="Calibri" panose="020F0502020204030204" pitchFamily="34" charset="0"/>
               </a:rPr>
-              <a:t>Random Forest Model:</a:t>
+              <a:t>Results:</a:t>
             </a:r>
             <a:br>
               <a:rPr lang="en-GB" sz="2400" b="1" dirty="0">
@@ -3650,21 +3882,14 @@
               </a:rPr>
             </a:br>
             <a:r>
-              <a:rPr lang="en-GB" sz="2400" b="1" dirty="0">
+              <a:rPr lang="en-GB" sz="1600" dirty="0" err="1">
                 <a:latin typeface="Calibri" panose="020F0502020204030204" pitchFamily="34" charset="0"/>
                 <a:ea typeface="Calibri" panose="020F0502020204030204" pitchFamily="34" charset="0"/>
                 <a:cs typeface="Calibri" panose="020F0502020204030204" pitchFamily="34" charset="0"/>
               </a:rPr>
-              <a:t>- </a:t>
-            </a:r>
-            <a:br>
-              <a:rPr lang="en-GB" sz="4400" b="1" dirty="0">
-                <a:latin typeface="Calibri" panose="020F0502020204030204" pitchFamily="34" charset="0"/>
-                <a:ea typeface="Calibri" panose="020F0502020204030204" pitchFamily="34" charset="0"/>
-                <a:cs typeface="Calibri" panose="020F0502020204030204" pitchFamily="34" charset="0"/>
-              </a:rPr>
-            </a:br>
-            <a:endParaRPr lang="en-GB" sz="4400" b="1" dirty="0">
+              <a:t>aaaaa</a:t>
+            </a:r>
+            <a:endParaRPr lang="en-GB" sz="1600" b="1" dirty="0">
               <a:latin typeface="Calibri" panose="020F0502020204030204" pitchFamily="34" charset="0"/>
               <a:ea typeface="Calibri" panose="020F0502020204030204" pitchFamily="34" charset="0"/>
               <a:cs typeface="Calibri" panose="020F0502020204030204" pitchFamily="34" charset="0"/>
@@ -3674,10 +3899,10 @@
       </p:sp>
       <p:sp>
         <p:nvSpPr>
-          <p:cNvPr id="13" name="Rectangle: Rounded Corners 12">
-            <a:extLst>
-              <a:ext uri="{FF2B5EF4-FFF2-40B4-BE49-F238E27FC236}">
-                <a16:creationId xmlns:a16="http://schemas.microsoft.com/office/drawing/2014/main" id="{5C5A3CF9-A1DF-AF30-4680-5E2CFF8DD8C3}"/>
+          <p:cNvPr id="3" name="Rectangle: Rounded Corners 2">
+            <a:extLst>
+              <a:ext uri="{FF2B5EF4-FFF2-40B4-BE49-F238E27FC236}">
+                <a16:creationId xmlns:a16="http://schemas.microsoft.com/office/drawing/2014/main" id="{F2935F09-33C9-CC38-97D3-73F5D052BE49}"/>
               </a:ext>
             </a:extLst>
           </p:cNvPr>
@@ -3686,83 +3911,20 @@
         </p:nvSpPr>
         <p:spPr>
           <a:xfrm>
-            <a:off x="11031312" y="23152338"/>
-            <a:ext cx="10123714" cy="6834549"/>
+            <a:off x="490047" y="7234064"/>
+            <a:ext cx="9972464" cy="3777333"/>
           </a:xfrm>
           <a:prstGeom prst="roundRect">
             <a:avLst/>
           </a:prstGeom>
-        </p:spPr>
-        <p:style>
-          <a:lnRef idx="1">
-            <a:schemeClr val="accent4"/>
-          </a:lnRef>
-          <a:fillRef idx="3">
-            <a:schemeClr val="accent4"/>
-          </a:fillRef>
-          <a:effectRef idx="2">
-            <a:schemeClr val="accent4"/>
-          </a:effectRef>
-          <a:fontRef idx="minor">
-            <a:schemeClr val="lt1"/>
-          </a:fontRef>
-        </p:style>
-        <p:txBody>
-          <a:bodyPr rtlCol="0" anchor="ctr"/>
-          <a:lstStyle/>
-          <a:p>
-            <a:r>
-              <a:rPr lang="en-GB" sz="4400" b="1" dirty="0">
-                <a:solidFill>
-                  <a:schemeClr val="tx1"/>
-                </a:solidFill>
-                <a:latin typeface="Calibri" panose="020F0502020204030204" pitchFamily="34" charset="0"/>
-                <a:ea typeface="Calibri" panose="020F0502020204030204" pitchFamily="34" charset="0"/>
-                <a:cs typeface="Calibri" panose="020F0502020204030204" pitchFamily="34" charset="0"/>
-              </a:rPr>
-              <a:t>Results &amp; Discussion:</a:t>
-            </a:r>
-            <a:br>
-              <a:rPr lang="en-GB" sz="4400" b="1" dirty="0">
-                <a:solidFill>
-                  <a:schemeClr val="tx1"/>
-                </a:solidFill>
-                <a:latin typeface="Calibri" panose="020F0502020204030204" pitchFamily="34" charset="0"/>
-                <a:ea typeface="Calibri" panose="020F0502020204030204" pitchFamily="34" charset="0"/>
-                <a:cs typeface="Calibri" panose="020F0502020204030204" pitchFamily="34" charset="0"/>
-              </a:rPr>
-            </a:br>
-            <a:endParaRPr lang="en-GB" sz="4400" dirty="0">
-              <a:solidFill>
-                <a:schemeClr val="tx1"/>
-              </a:solidFill>
-              <a:latin typeface="Calibri" panose="020F0502020204030204" pitchFamily="34" charset="0"/>
-              <a:ea typeface="Calibri" panose="020F0502020204030204" pitchFamily="34" charset="0"/>
-              <a:cs typeface="Calibri" panose="020F0502020204030204" pitchFamily="34" charset="0"/>
-            </a:endParaRPr>
-          </a:p>
-        </p:txBody>
-      </p:sp>
-      <p:sp>
-        <p:nvSpPr>
-          <p:cNvPr id="14" name="Rectangle: Rounded Corners 13">
-            <a:extLst>
-              <a:ext uri="{FF2B5EF4-FFF2-40B4-BE49-F238E27FC236}">
-                <a16:creationId xmlns:a16="http://schemas.microsoft.com/office/drawing/2014/main" id="{8E6298C8-913F-3313-A467-E69E9967C7E6}"/>
-              </a:ext>
-            </a:extLst>
-          </p:cNvPr>
-          <p:cNvSpPr/>
-          <p:nvPr/>
-        </p:nvSpPr>
-        <p:spPr>
-          <a:xfrm>
-            <a:off x="228599" y="16631693"/>
-            <a:ext cx="10123714" cy="6834549"/>
-          </a:xfrm>
-          <a:prstGeom prst="roundRect">
-            <a:avLst/>
-          </a:prstGeom>
+          <a:solidFill>
+            <a:schemeClr val="bg1"/>
+          </a:solidFill>
+          <a:ln w="254000">
+            <a:solidFill>
+              <a:schemeClr val="tx2"/>
+            </a:solidFill>
+          </a:ln>
         </p:spPr>
         <p:style>
           <a:lnRef idx="1">
@@ -3783,14 +3945,102 @@
           <a:lstStyle/>
           <a:p>
             <a:r>
-              <a:rPr lang="en-GB" sz="4400" b="1" dirty="0">
+              <a:rPr lang="en-GB" sz="2400" b="1" dirty="0">
+                <a:solidFill>
+                  <a:schemeClr val="tx1"/>
+                </a:solidFill>
                 <a:latin typeface="Calibri" panose="020F0502020204030204" pitchFamily="34" charset="0"/>
                 <a:ea typeface="Calibri" panose="020F0502020204030204" pitchFamily="34" charset="0"/>
                 <a:cs typeface="Calibri" panose="020F0502020204030204" pitchFamily="34" charset="0"/>
               </a:rPr>
-              <a:t>Development Methods:</a:t>
-            </a:r>
-            <a:endParaRPr lang="en-GB" sz="4400" dirty="0">
+              <a:t>Data Collection &amp; Preprocessing:</a:t>
+            </a:r>
+            <a:br>
+              <a:rPr lang="en-GB" sz="2400" b="1" dirty="0">
+                <a:solidFill>
+                  <a:schemeClr val="tx1"/>
+                </a:solidFill>
+                <a:latin typeface="Calibri" panose="020F0502020204030204" pitchFamily="34" charset="0"/>
+                <a:ea typeface="Calibri" panose="020F0502020204030204" pitchFamily="34" charset="0"/>
+                <a:cs typeface="Calibri" panose="020F0502020204030204" pitchFamily="34" charset="0"/>
+              </a:rPr>
+            </a:br>
+            <a:r>
+              <a:rPr lang="en-GB" sz="1600" dirty="0">
+                <a:solidFill>
+                  <a:schemeClr val="tx1"/>
+                </a:solidFill>
+                <a:latin typeface="Calibri" panose="020F0502020204030204" pitchFamily="34" charset="0"/>
+                <a:ea typeface="Calibri" panose="020F0502020204030204" pitchFamily="34" charset="0"/>
+                <a:cs typeface="Calibri" panose="020F0502020204030204" pitchFamily="34" charset="0"/>
+              </a:rPr>
+              <a:t>Publicly available telemetric data from real Formula One races were accessed using the FastF1 Python library. From here, taking all fast-lap qualifying data from events under dry conditions to form the historical dataset.</a:t>
+            </a:r>
+          </a:p>
+          <a:p>
+            <a:r>
+              <a:rPr lang="en-GB" sz="1600" b="1" dirty="0">
+                <a:solidFill>
+                  <a:schemeClr val="tx1"/>
+                </a:solidFill>
+                <a:latin typeface="Calibri" panose="020F0502020204030204" pitchFamily="34" charset="0"/>
+                <a:ea typeface="Calibri" panose="020F0502020204030204" pitchFamily="34" charset="0"/>
+                <a:cs typeface="Calibri" panose="020F0502020204030204" pitchFamily="34" charset="0"/>
+              </a:rPr>
+              <a:t>AI (CPU) qualifying data from the F1 25 game was harvested using Telemetry Tool by Iko Rein.</a:t>
+            </a:r>
+            <a:r>
+              <a:rPr lang="en-GB" sz="1600" dirty="0">
+                <a:solidFill>
+                  <a:schemeClr val="tx1"/>
+                </a:solidFill>
+                <a:latin typeface="Calibri" panose="020F0502020204030204" pitchFamily="34" charset="0"/>
+                <a:ea typeface="Calibri" panose="020F0502020204030204" pitchFamily="34" charset="0"/>
+                <a:cs typeface="Calibri" panose="020F0502020204030204" pitchFamily="34" charset="0"/>
+              </a:rPr>
+              <a:t> </a:t>
+            </a:r>
+            <a:r>
+              <a:rPr lang="en-GB" sz="1600" b="1" dirty="0">
+                <a:solidFill>
+                  <a:schemeClr val="tx1"/>
+                </a:solidFill>
+                <a:latin typeface="Calibri" panose="020F0502020204030204" pitchFamily="34" charset="0"/>
+                <a:ea typeface="Calibri" panose="020F0502020204030204" pitchFamily="34" charset="0"/>
+                <a:cs typeface="Calibri" panose="020F0502020204030204" pitchFamily="34" charset="0"/>
+              </a:rPr>
+              <a:t>This was run under conditions with equal performance across all cars, as well as exclusively time-fixed dry conditions to eliminate potential variability.</a:t>
+            </a:r>
+          </a:p>
+          <a:p>
+            <a:r>
+              <a:rPr lang="en-GB" sz="1600" dirty="0">
+                <a:solidFill>
+                  <a:schemeClr val="tx1"/>
+                </a:solidFill>
+                <a:latin typeface="Calibri" panose="020F0502020204030204" pitchFamily="34" charset="0"/>
+                <a:ea typeface="Calibri" panose="020F0502020204030204" pitchFamily="34" charset="0"/>
+                <a:cs typeface="Calibri" panose="020F0502020204030204" pitchFamily="34" charset="0"/>
+              </a:rPr>
+              <a:t>Preprocessing was applied to all data collected. Historical data throttle and braking values were binarised and was temporally interpolated to every 0.05s (20hz). Game coordinates were realigned to match real-world values, with its throttle and braking values normalised to 0-1. The data were also interpolated to match 5 metre track intervals, appropriate for the 20hz sample intervals, so that comparisons between laps had reliable accuracy. </a:t>
+            </a:r>
+          </a:p>
+          <a:p>
+            <a:r>
+              <a:rPr lang="en-GB" sz="1600" b="1" dirty="0">
+                <a:solidFill>
+                  <a:schemeClr val="tx1"/>
+                </a:solidFill>
+                <a:latin typeface="Calibri" panose="020F0502020204030204" pitchFamily="34" charset="0"/>
+                <a:ea typeface="Calibri" panose="020F0502020204030204" pitchFamily="34" charset="0"/>
+                <a:cs typeface="Calibri" panose="020F0502020204030204" pitchFamily="34" charset="0"/>
+              </a:rPr>
+              <a:t>Data had the following columns: distance, x, y, z, norm_speed, speed, time, throttle, brake, gear, drs, rpm, source.</a:t>
+            </a:r>
+            <a:endParaRPr lang="en-GB" sz="2400" b="1" dirty="0">
+              <a:solidFill>
+                <a:schemeClr val="tx1"/>
+              </a:solidFill>
               <a:latin typeface="Calibri" panose="020F0502020204030204" pitchFamily="34" charset="0"/>
               <a:ea typeface="Calibri" panose="020F0502020204030204" pitchFamily="34" charset="0"/>
               <a:cs typeface="Calibri" panose="020F0502020204030204" pitchFamily="34" charset="0"/>
@@ -3798,12 +4048,245 @@
           </a:p>
         </p:txBody>
       </p:sp>
+      <p:grpSp>
+        <p:nvGrpSpPr>
+          <p:cNvPr id="11" name="Group 10">
+            <a:extLst>
+              <a:ext uri="{FF2B5EF4-FFF2-40B4-BE49-F238E27FC236}">
+                <a16:creationId xmlns:a16="http://schemas.microsoft.com/office/drawing/2014/main" id="{3BFB25DB-8FD1-81DD-DCF0-2F3EE7C54E67}"/>
+              </a:ext>
+            </a:extLst>
+          </p:cNvPr>
+          <p:cNvGrpSpPr/>
+          <p:nvPr/>
+        </p:nvGrpSpPr>
+        <p:grpSpPr>
+          <a:xfrm>
+            <a:off x="12866423" y="3941880"/>
+            <a:ext cx="6154817" cy="2783671"/>
+            <a:chOff x="10801687" y="4065336"/>
+            <a:chExt cx="6154817" cy="2783671"/>
+          </a:xfrm>
+        </p:grpSpPr>
+        <p:pic>
+          <p:nvPicPr>
+            <p:cNvPr id="20" name="Picture 19">
+              <a:extLst>
+                <a:ext uri="{FF2B5EF4-FFF2-40B4-BE49-F238E27FC236}">
+                  <a16:creationId xmlns:a16="http://schemas.microsoft.com/office/drawing/2014/main" id="{CFD3E36D-F382-F785-206B-D605246EFCD7}"/>
+                </a:ext>
+              </a:extLst>
+            </p:cNvPr>
+            <p:cNvPicPr>
+              <a:picLocks noChangeAspect="1"/>
+            </p:cNvPicPr>
+            <p:nvPr/>
+          </p:nvPicPr>
+          <p:blipFill>
+            <a:blip r:embed="rId3"/>
+            <a:stretch>
+              <a:fillRect/>
+            </a:stretch>
+          </p:blipFill>
+          <p:spPr>
+            <a:xfrm>
+              <a:off x="10915879" y="4065336"/>
+              <a:ext cx="5723940" cy="2578918"/>
+            </a:xfrm>
+            <a:prstGeom prst="rect">
+              <a:avLst/>
+            </a:prstGeom>
+          </p:spPr>
+        </p:pic>
+        <p:sp>
+          <p:nvSpPr>
+            <p:cNvPr id="10" name="TextBox 9">
+              <a:extLst>
+                <a:ext uri="{FF2B5EF4-FFF2-40B4-BE49-F238E27FC236}">
+                  <a16:creationId xmlns:a16="http://schemas.microsoft.com/office/drawing/2014/main" id="{CA9944B3-6E95-E157-44E2-27265B6D8B79}"/>
+                </a:ext>
+              </a:extLst>
+            </p:cNvPr>
+            <p:cNvSpPr txBox="1"/>
+            <p:nvPr/>
+          </p:nvSpPr>
+          <p:spPr>
+            <a:xfrm>
+              <a:off x="10801687" y="6510453"/>
+              <a:ext cx="6154817" cy="338554"/>
+            </a:xfrm>
+            <a:prstGeom prst="rect">
+              <a:avLst/>
+            </a:prstGeom>
+            <a:noFill/>
+          </p:spPr>
+          <p:txBody>
+            <a:bodyPr wrap="square" rtlCol="0">
+              <a:spAutoFit/>
+            </a:bodyPr>
+            <a:lstStyle/>
+            <a:p>
+              <a:r>
+                <a:rPr lang="en-GB" sz="1600" b="1" dirty="0"/>
+                <a:t>Figure 1: </a:t>
+              </a:r>
+              <a:r>
+                <a:rPr lang="en-GB" sz="1600" dirty="0"/>
+                <a:t>Curvature over Distance Plot for the Red Bull Ring (Austria).</a:t>
+              </a:r>
+              <a:endParaRPr lang="en-GB" sz="1600" b="1" dirty="0"/>
+            </a:p>
+          </p:txBody>
+        </p:sp>
+      </p:grpSp>
+      <p:grpSp>
+        <p:nvGrpSpPr>
+          <p:cNvPr id="19" name="Group 18">
+            <a:extLst>
+              <a:ext uri="{FF2B5EF4-FFF2-40B4-BE49-F238E27FC236}">
+                <a16:creationId xmlns:a16="http://schemas.microsoft.com/office/drawing/2014/main" id="{F4BC4623-EAD9-CB3F-B5B3-CC881163C38B}"/>
+              </a:ext>
+            </a:extLst>
+          </p:cNvPr>
+          <p:cNvGrpSpPr/>
+          <p:nvPr/>
+        </p:nvGrpSpPr>
+        <p:grpSpPr>
+          <a:xfrm>
+            <a:off x="14079738" y="6849523"/>
+            <a:ext cx="3530656" cy="3800024"/>
+            <a:chOff x="10845672" y="6707406"/>
+            <a:chExt cx="4123314" cy="3585470"/>
+          </a:xfrm>
+        </p:grpSpPr>
+        <p:grpSp>
+          <p:nvGrpSpPr>
+            <p:cNvPr id="15" name="Group 14">
+              <a:extLst>
+                <a:ext uri="{FF2B5EF4-FFF2-40B4-BE49-F238E27FC236}">
+                  <a16:creationId xmlns:a16="http://schemas.microsoft.com/office/drawing/2014/main" id="{2C11DD64-CABE-CA55-55CE-448EDC0C8F4E}"/>
+                </a:ext>
+              </a:extLst>
+            </p:cNvPr>
+            <p:cNvGrpSpPr/>
+            <p:nvPr/>
+          </p:nvGrpSpPr>
+          <p:grpSpPr>
+            <a:xfrm>
+              <a:off x="11042337" y="6707406"/>
+              <a:ext cx="3739242" cy="2916740"/>
+              <a:chOff x="10915877" y="7365592"/>
+              <a:chExt cx="3739242" cy="2916740"/>
+            </a:xfrm>
+          </p:grpSpPr>
+          <p:pic>
+            <p:nvPicPr>
+              <p:cNvPr id="16" name="Picture 15">
+                <a:extLst>
+                  <a:ext uri="{FF2B5EF4-FFF2-40B4-BE49-F238E27FC236}">
+                    <a16:creationId xmlns:a16="http://schemas.microsoft.com/office/drawing/2014/main" id="{8C629B29-B49F-AE4D-B983-68DF8FC4E32E}"/>
+                  </a:ext>
+                </a:extLst>
+              </p:cNvPr>
+              <p:cNvPicPr>
+                <a:picLocks noChangeAspect="1"/>
+              </p:cNvPicPr>
+              <p:nvPr/>
+            </p:nvPicPr>
+            <p:blipFill>
+              <a:blip r:embed="rId4"/>
+              <a:stretch>
+                <a:fillRect/>
+              </a:stretch>
+            </p:blipFill>
+            <p:spPr>
+              <a:xfrm>
+                <a:off x="10915877" y="7365592"/>
+                <a:ext cx="1980337" cy="2916740"/>
+              </a:xfrm>
+              <a:prstGeom prst="rect">
+                <a:avLst/>
+              </a:prstGeom>
+            </p:spPr>
+          </p:pic>
+          <p:pic>
+            <p:nvPicPr>
+              <p:cNvPr id="18" name="Picture 17">
+                <a:extLst>
+                  <a:ext uri="{FF2B5EF4-FFF2-40B4-BE49-F238E27FC236}">
+                    <a16:creationId xmlns:a16="http://schemas.microsoft.com/office/drawing/2014/main" id="{4EAF249F-FBD2-2B79-F522-372ED78F52BC}"/>
+                  </a:ext>
+                </a:extLst>
+              </p:cNvPr>
+              <p:cNvPicPr>
+                <a:picLocks noChangeAspect="1"/>
+              </p:cNvPicPr>
+              <p:nvPr/>
+            </p:nvPicPr>
+            <p:blipFill>
+              <a:blip r:embed="rId5"/>
+              <a:stretch>
+                <a:fillRect/>
+              </a:stretch>
+            </p:blipFill>
+            <p:spPr>
+              <a:xfrm>
+                <a:off x="12896214" y="7384257"/>
+                <a:ext cx="1758905" cy="2883888"/>
+              </a:xfrm>
+              <a:prstGeom prst="rect">
+                <a:avLst/>
+              </a:prstGeom>
+            </p:spPr>
+          </p:pic>
+        </p:grpSp>
+        <p:sp>
+          <p:nvSpPr>
+            <p:cNvPr id="17" name="TextBox 16">
+              <a:extLst>
+                <a:ext uri="{FF2B5EF4-FFF2-40B4-BE49-F238E27FC236}">
+                  <a16:creationId xmlns:a16="http://schemas.microsoft.com/office/drawing/2014/main" id="{8D17F905-2A11-8104-169A-6083B82773C8}"/>
+                </a:ext>
+              </a:extLst>
+            </p:cNvPr>
+            <p:cNvSpPr txBox="1"/>
+            <p:nvPr/>
+          </p:nvSpPr>
+          <p:spPr>
+            <a:xfrm>
+              <a:off x="10845672" y="9741118"/>
+              <a:ext cx="4123314" cy="551758"/>
+            </a:xfrm>
+            <a:prstGeom prst="rect">
+              <a:avLst/>
+            </a:prstGeom>
+            <a:noFill/>
+          </p:spPr>
+          <p:txBody>
+            <a:bodyPr wrap="square" rtlCol="0">
+              <a:spAutoFit/>
+            </a:bodyPr>
+            <a:lstStyle/>
+            <a:p>
+              <a:r>
+                <a:rPr lang="en-GB" sz="1600" b="1" dirty="0"/>
+                <a:t>Figures 2 &amp; 3: </a:t>
+              </a:r>
+              <a:r>
+                <a:rPr lang="en-GB" sz="1600" dirty="0"/>
+                <a:t>Car State and Speed plots for the Red Bull Ring (Austria).</a:t>
+              </a:r>
+              <a:endParaRPr lang="en-GB" sz="1600" b="1" dirty="0"/>
+            </a:p>
+          </p:txBody>
+        </p:sp>
+      </p:grpSp>
       <p:pic>
         <p:nvPicPr>
-          <p:cNvPr id="16" name="Picture 15">
-            <a:extLst>
-              <a:ext uri="{FF2B5EF4-FFF2-40B4-BE49-F238E27FC236}">
-                <a16:creationId xmlns:a16="http://schemas.microsoft.com/office/drawing/2014/main" id="{8C629B29-B49F-AE4D-B983-68DF8FC4E32E}"/>
+          <p:cNvPr id="22" name="Picture 21">
+            <a:extLst>
+              <a:ext uri="{FF2B5EF4-FFF2-40B4-BE49-F238E27FC236}">
+                <a16:creationId xmlns:a16="http://schemas.microsoft.com/office/drawing/2014/main" id="{1F60DBE7-CAD8-922C-A22A-F395D5F75435}"/>
               </a:ext>
             </a:extLst>
           </p:cNvPr>
@@ -3813,15 +4296,15 @@
           <p:nvPr/>
         </p:nvPicPr>
         <p:blipFill>
-          <a:blip r:embed="rId3"/>
+          <a:blip r:embed="rId6"/>
           <a:stretch>
             <a:fillRect/>
           </a:stretch>
         </p:blipFill>
         <p:spPr>
           <a:xfrm>
-            <a:off x="237971" y="11482846"/>
-            <a:ext cx="3354315" cy="4940405"/>
+            <a:off x="2365167" y="11682574"/>
+            <a:ext cx="5225229" cy="2340562"/>
           </a:xfrm>
           <a:prstGeom prst="rect">
             <a:avLst/>
@@ -3830,10 +4313,10 @@
       </p:pic>
       <p:pic>
         <p:nvPicPr>
-          <p:cNvPr id="18" name="Picture 17">
-            <a:extLst>
-              <a:ext uri="{FF2B5EF4-FFF2-40B4-BE49-F238E27FC236}">
-                <a16:creationId xmlns:a16="http://schemas.microsoft.com/office/drawing/2014/main" id="{4EAF249F-FBD2-2B79-F522-372ED78F52BC}"/>
+          <p:cNvPr id="24" name="Picture 23">
+            <a:extLst>
+              <a:ext uri="{FF2B5EF4-FFF2-40B4-BE49-F238E27FC236}">
+                <a16:creationId xmlns:a16="http://schemas.microsoft.com/office/drawing/2014/main" id="{36F8C087-00E0-D9B9-F42A-069442A99ABB}"/>
               </a:ext>
             </a:extLst>
           </p:cNvPr>
@@ -3843,15 +4326,15 @@
           <p:nvPr/>
         </p:nvPicPr>
         <p:blipFill>
-          <a:blip r:embed="rId4"/>
+          <a:blip r:embed="rId7"/>
           <a:stretch>
             <a:fillRect/>
           </a:stretch>
         </p:blipFill>
         <p:spPr>
           <a:xfrm>
-            <a:off x="7339125" y="11482846"/>
-            <a:ext cx="3013188" cy="4940405"/>
+            <a:off x="2266186" y="14468852"/>
+            <a:ext cx="6268934" cy="2563968"/>
           </a:xfrm>
           <a:prstGeom prst="rect">
             <a:avLst/>
@@ -3860,10 +4343,10 @@
       </p:pic>
       <p:pic>
         <p:nvPicPr>
-          <p:cNvPr id="20" name="Picture 19">
-            <a:extLst>
-              <a:ext uri="{FF2B5EF4-FFF2-40B4-BE49-F238E27FC236}">
-                <a16:creationId xmlns:a16="http://schemas.microsoft.com/office/drawing/2014/main" id="{CFD3E36D-F382-F785-206B-D605246EFCD7}"/>
+          <p:cNvPr id="30" name="Picture 29">
+            <a:extLst>
+              <a:ext uri="{FF2B5EF4-FFF2-40B4-BE49-F238E27FC236}">
+                <a16:creationId xmlns:a16="http://schemas.microsoft.com/office/drawing/2014/main" id="{D2F64817-0EB2-E5E8-47C4-F7473A4533F6}"/>
               </a:ext>
             </a:extLst>
           </p:cNvPr>
@@ -3873,21 +4356,178 @@
           <p:nvPr/>
         </p:nvPicPr>
         <p:blipFill>
-          <a:blip r:embed="rId5"/>
+          <a:blip r:embed="rId8"/>
+          <a:srcRect l="3870"/>
           <a:stretch>
             <a:fillRect/>
           </a:stretch>
         </p:blipFill>
         <p:spPr>
           <a:xfrm>
-            <a:off x="11031312" y="4510709"/>
-            <a:ext cx="9774138" cy="4403733"/>
+            <a:off x="13320933" y="18369187"/>
+            <a:ext cx="5250755" cy="4642821"/>
           </a:xfrm>
           <a:prstGeom prst="rect">
             <a:avLst/>
           </a:prstGeom>
         </p:spPr>
       </p:pic>
+      <p:sp>
+        <p:nvSpPr>
+          <p:cNvPr id="45" name="Rectangle: Rounded Corners 44">
+            <a:extLst>
+              <a:ext uri="{FF2B5EF4-FFF2-40B4-BE49-F238E27FC236}">
+                <a16:creationId xmlns:a16="http://schemas.microsoft.com/office/drawing/2014/main" id="{4763A920-50C0-2CA3-7F95-83106B143CB1}"/>
+              </a:ext>
+            </a:extLst>
+          </p:cNvPr>
+          <p:cNvSpPr/>
+          <p:nvPr/>
+        </p:nvSpPr>
+        <p:spPr>
+          <a:xfrm>
+            <a:off x="10980981" y="23936248"/>
+            <a:ext cx="9957091" cy="5824704"/>
+          </a:xfrm>
+          <a:prstGeom prst="roundRect">
+            <a:avLst/>
+          </a:prstGeom>
+          <a:solidFill>
+            <a:schemeClr val="bg1"/>
+          </a:solidFill>
+          <a:ln w="254000">
+            <a:solidFill>
+              <a:schemeClr val="tx2"/>
+            </a:solidFill>
+          </a:ln>
+        </p:spPr>
+        <p:style>
+          <a:lnRef idx="1">
+            <a:schemeClr val="accent4"/>
+          </a:lnRef>
+          <a:fillRef idx="2">
+            <a:schemeClr val="accent4"/>
+          </a:fillRef>
+          <a:effectRef idx="1">
+            <a:schemeClr val="accent4"/>
+          </a:effectRef>
+          <a:fontRef idx="minor">
+            <a:schemeClr val="dk1"/>
+          </a:fontRef>
+        </p:style>
+        <p:txBody>
+          <a:bodyPr rtlCol="0" anchor="ctr"/>
+          <a:lstStyle/>
+          <a:p>
+            <a:r>
+              <a:rPr lang="en-GB" sz="2400" b="1" dirty="0">
+                <a:latin typeface="Calibri" panose="020F0502020204030204" pitchFamily="34" charset="0"/>
+                <a:ea typeface="Calibri" panose="020F0502020204030204" pitchFamily="34" charset="0"/>
+                <a:cs typeface="Calibri" panose="020F0502020204030204" pitchFamily="34" charset="0"/>
+              </a:rPr>
+              <a:t>Discussion &amp; Future Work:</a:t>
+            </a:r>
+            <a:br>
+              <a:rPr lang="en-GB" sz="2400" b="1" dirty="0">
+                <a:latin typeface="Calibri" panose="020F0502020204030204" pitchFamily="34" charset="0"/>
+                <a:ea typeface="Calibri" panose="020F0502020204030204" pitchFamily="34" charset="0"/>
+                <a:cs typeface="Calibri" panose="020F0502020204030204" pitchFamily="34" charset="0"/>
+              </a:rPr>
+            </a:br>
+            <a:r>
+              <a:rPr lang="en-GB" sz="1600" dirty="0" err="1">
+                <a:latin typeface="Calibri" panose="020F0502020204030204" pitchFamily="34" charset="0"/>
+                <a:ea typeface="Calibri" panose="020F0502020204030204" pitchFamily="34" charset="0"/>
+                <a:cs typeface="Calibri" panose="020F0502020204030204" pitchFamily="34" charset="0"/>
+              </a:rPr>
+              <a:t>aaaa</a:t>
+            </a:r>
+            <a:endParaRPr lang="en-GB" sz="2400" b="1" dirty="0">
+              <a:latin typeface="Calibri" panose="020F0502020204030204" pitchFamily="34" charset="0"/>
+              <a:ea typeface="Calibri" panose="020F0502020204030204" pitchFamily="34" charset="0"/>
+              <a:cs typeface="Calibri" panose="020F0502020204030204" pitchFamily="34" charset="0"/>
+            </a:endParaRPr>
+          </a:p>
+        </p:txBody>
+      </p:sp>
+      <p:sp>
+        <p:nvSpPr>
+          <p:cNvPr id="47" name="Rectangle: Rounded Corners 46">
+            <a:extLst>
+              <a:ext uri="{FF2B5EF4-FFF2-40B4-BE49-F238E27FC236}">
+                <a16:creationId xmlns:a16="http://schemas.microsoft.com/office/drawing/2014/main" id="{BEB09868-B3B9-7F72-E19F-60716C2E67D6}"/>
+              </a:ext>
+            </a:extLst>
+          </p:cNvPr>
+          <p:cNvSpPr/>
+          <p:nvPr/>
+        </p:nvSpPr>
+        <p:spPr>
+          <a:xfrm>
+            <a:off x="10965285" y="11466018"/>
+            <a:ext cx="9957091" cy="5824704"/>
+          </a:xfrm>
+          <a:prstGeom prst="roundRect">
+            <a:avLst/>
+          </a:prstGeom>
+          <a:solidFill>
+            <a:schemeClr val="bg1"/>
+          </a:solidFill>
+          <a:ln w="254000">
+            <a:solidFill>
+              <a:schemeClr val="tx2"/>
+            </a:solidFill>
+          </a:ln>
+        </p:spPr>
+        <p:style>
+          <a:lnRef idx="1">
+            <a:schemeClr val="accent4"/>
+          </a:lnRef>
+          <a:fillRef idx="2">
+            <a:schemeClr val="accent4"/>
+          </a:fillRef>
+          <a:effectRef idx="1">
+            <a:schemeClr val="accent4"/>
+          </a:effectRef>
+          <a:fontRef idx="minor">
+            <a:schemeClr val="dk1"/>
+          </a:fontRef>
+        </p:style>
+        <p:txBody>
+          <a:bodyPr rtlCol="0" anchor="ctr"/>
+          <a:lstStyle/>
+          <a:p>
+            <a:r>
+              <a:rPr lang="en-GB" sz="2400" b="1" dirty="0">
+                <a:latin typeface="Calibri" panose="020F0502020204030204" pitchFamily="34" charset="0"/>
+                <a:ea typeface="Calibri" panose="020F0502020204030204" pitchFamily="34" charset="0"/>
+                <a:cs typeface="Calibri" panose="020F0502020204030204" pitchFamily="34" charset="0"/>
+              </a:rPr>
+              <a:t>Results:</a:t>
+            </a:r>
+            <a:br>
+              <a:rPr lang="en-GB" sz="2400" b="1" dirty="0">
+                <a:latin typeface="Calibri" panose="020F0502020204030204" pitchFamily="34" charset="0"/>
+                <a:ea typeface="Calibri" panose="020F0502020204030204" pitchFamily="34" charset="0"/>
+                <a:cs typeface="Calibri" panose="020F0502020204030204" pitchFamily="34" charset="0"/>
+              </a:rPr>
+            </a:br>
+            <a:r>
+              <a:rPr lang="en-GB" sz="1600" dirty="0" err="1">
+                <a:latin typeface="Calibri" panose="020F0502020204030204" pitchFamily="34" charset="0"/>
+                <a:ea typeface="Calibri" panose="020F0502020204030204" pitchFamily="34" charset="0"/>
+                <a:cs typeface="Calibri" panose="020F0502020204030204" pitchFamily="34" charset="0"/>
+              </a:rPr>
+              <a:t>aaaaa</a:t>
+            </a:r>
+            <a:endParaRPr lang="en-GB" sz="1600" b="1" dirty="0">
+              <a:latin typeface="Calibri" panose="020F0502020204030204" pitchFamily="34" charset="0"/>
+              <a:ea typeface="Calibri" panose="020F0502020204030204" pitchFamily="34" charset="0"/>
+              <a:cs typeface="Calibri" panose="020F0502020204030204" pitchFamily="34" charset="0"/>
+            </a:endParaRPr>
+          </a:p>
+        </p:txBody>
+      </p:sp>
     </p:spTree>
     <p:extLst>
       <p:ext uri="{BB962C8B-B14F-4D97-AF65-F5344CB8AC3E}">

</xml_diff>

<commit_message>
Poster update (31/3/26 6pm)
</commit_message>
<xml_diff>
--- a/Presentation1.pptx
+++ b/Presentation1.pptx
@@ -3380,7 +3380,7 @@
         </p:nvSpPr>
         <p:spPr>
           <a:xfrm>
-            <a:off x="10980981" y="23936248"/>
+            <a:off x="10978646" y="23832754"/>
             <a:ext cx="9957091" cy="5824704"/>
           </a:xfrm>
           <a:prstGeom prst="roundRect">
@@ -3717,7 +3717,7 @@
         </p:nvSpPr>
         <p:spPr>
           <a:xfrm>
-            <a:off x="445553" y="23936248"/>
+            <a:off x="443217" y="23832754"/>
             <a:ext cx="9957091" cy="5824704"/>
           </a:xfrm>
           <a:prstGeom prst="roundRect">
@@ -3896,7 +3896,7 @@
         </p:nvSpPr>
         <p:spPr>
           <a:xfrm>
-            <a:off x="10978646" y="17778247"/>
+            <a:off x="10978646" y="17657612"/>
             <a:ext cx="9957091" cy="5824704"/>
           </a:xfrm>
           <a:prstGeom prst="roundRect">
@@ -4085,8 +4085,8 @@
         </p:nvSpPr>
         <p:spPr>
           <a:xfrm>
-            <a:off x="10975632" y="3588017"/>
-            <a:ext cx="9943729" cy="7423380"/>
+            <a:off x="10978646" y="3588017"/>
+            <a:ext cx="9940715" cy="7508224"/>
           </a:xfrm>
           <a:prstGeom prst="roundRect">
             <a:avLst/>
@@ -4390,7 +4390,7 @@
         <p:spPr>
           <a:xfrm>
             <a:off x="427845" y="3588017"/>
-            <a:ext cx="9972463" cy="3300122"/>
+            <a:ext cx="9972463" cy="3337840"/>
           </a:xfrm>
           <a:prstGeom prst="roundRect">
             <a:avLst/>
@@ -4484,7 +4484,7 @@
         </p:nvSpPr>
         <p:spPr>
           <a:xfrm>
-            <a:off x="443218" y="17778247"/>
+            <a:off x="443217" y="17657612"/>
             <a:ext cx="9957091" cy="5824704"/>
           </a:xfrm>
           <a:prstGeom prst="roundRect">
@@ -4920,8 +4920,8 @@
         </p:nvSpPr>
         <p:spPr>
           <a:xfrm>
-            <a:off x="435530" y="7234064"/>
-            <a:ext cx="9972464" cy="3777333"/>
+            <a:off x="427844" y="7275736"/>
+            <a:ext cx="9972464" cy="3820505"/>
           </a:xfrm>
           <a:prstGeom prst="roundRect">
             <a:avLst/>
@@ -5841,7 +5841,7 @@
         </p:blipFill>
         <p:spPr>
           <a:xfrm>
-            <a:off x="1014101" y="12477171"/>
+            <a:off x="1014101" y="12464471"/>
             <a:ext cx="5374776" cy="4620118"/>
           </a:xfrm>
           <a:prstGeom prst="rect">
@@ -6217,7 +6217,7 @@
         </p:nvGrpSpPr>
         <p:grpSpPr>
           <a:xfrm>
-            <a:off x="5442536" y="24286686"/>
+            <a:off x="5442536" y="24161994"/>
             <a:ext cx="4541593" cy="2561914"/>
             <a:chOff x="5009622" y="24620561"/>
             <a:chExt cx="4541593" cy="2561914"/>
@@ -6310,7 +6310,7 @@
         </p:nvGrpSpPr>
         <p:grpSpPr>
           <a:xfrm>
-            <a:off x="5440811" y="26858203"/>
+            <a:off x="5440811" y="26733511"/>
             <a:ext cx="4541593" cy="2753206"/>
             <a:chOff x="5161917" y="26796290"/>
             <a:chExt cx="4541593" cy="2753206"/>

</xml_diff>